<commit_message>
Add final test evaluation evidence
</commit_message>
<xml_diff>
--- a/outputs/manual-20260614-insy684-deck/presentations/insy684-mlops-technical-deck/output/insy684-mlops-technical-section.pptx
+++ b/outputs/manual-20260614-insy684-deck/presentations/insy684-mlops-technical-deck/output/insy684-mlops-technical-section.pptx
@@ -2,23 +2,23 @@
 <file path=ppt/presentation.xml><?xml version="1.0" encoding="utf-8"?>
 <p:presentation xmlns:p="http://schemas.openxmlformats.org/presentationml/2006/main">
   <p:sldMasterIdLst>
-    <p:sldMasterId xmlns:r="http://schemas.openxmlformats.org/officeDocument/2006/relationships" id="2147483648" r:id="Re4a19c0c5cf94f4b"/>
+    <p:sldMasterId xmlns:r="http://schemas.openxmlformats.org/officeDocument/2006/relationships" id="2147483648" r:id="Rbe1e5fc5f34e4697"/>
   </p:sldMasterIdLst>
   <p:notesMasterIdLst>
-    <p:notesMasterId xmlns:r="http://schemas.openxmlformats.org/officeDocument/2006/relationships" r:id="R873d3068307b44af"/>
+    <p:notesMasterId xmlns:r="http://schemas.openxmlformats.org/officeDocument/2006/relationships" r:id="R804a838f977b4008"/>
   </p:notesMasterIdLst>
   <p:sldIdLst>
-    <p:sldId xmlns:r="http://schemas.openxmlformats.org/officeDocument/2006/relationships" id="256" r:id="R9346e954fd6141b4"/>
-    <p:sldId xmlns:r="http://schemas.openxmlformats.org/officeDocument/2006/relationships" id="257" r:id="R9d2fa77f97354c8a"/>
-    <p:sldId xmlns:r="http://schemas.openxmlformats.org/officeDocument/2006/relationships" id="258" r:id="Rcce95fcda1534bd1"/>
-    <p:sldId xmlns:r="http://schemas.openxmlformats.org/officeDocument/2006/relationships" id="259" r:id="R23547d9567754091"/>
-    <p:sldId xmlns:r="http://schemas.openxmlformats.org/officeDocument/2006/relationships" id="260" r:id="R31fd92bd18764df7"/>
-    <p:sldId xmlns:r="http://schemas.openxmlformats.org/officeDocument/2006/relationships" id="261" r:id="R2faf8875408147f1"/>
-    <p:sldId xmlns:r="http://schemas.openxmlformats.org/officeDocument/2006/relationships" id="262" r:id="R6d40a13831aa4e25"/>
-    <p:sldId xmlns:r="http://schemas.openxmlformats.org/officeDocument/2006/relationships" id="263" r:id="Ra61d9b7663034c95"/>
-    <p:sldId xmlns:r="http://schemas.openxmlformats.org/officeDocument/2006/relationships" id="264" r:id="Rac8aca26e5a84f24"/>
-    <p:sldId xmlns:r="http://schemas.openxmlformats.org/officeDocument/2006/relationships" id="265" r:id="R90fd69e3625d41c4"/>
-    <p:sldId xmlns:r="http://schemas.openxmlformats.org/officeDocument/2006/relationships" id="266" r:id="R00105bffdad14958"/>
+    <p:sldId xmlns:r="http://schemas.openxmlformats.org/officeDocument/2006/relationships" id="256" r:id="R0e691822c7a14e67"/>
+    <p:sldId xmlns:r="http://schemas.openxmlformats.org/officeDocument/2006/relationships" id="257" r:id="R0d1cde76c6e44215"/>
+    <p:sldId xmlns:r="http://schemas.openxmlformats.org/officeDocument/2006/relationships" id="258" r:id="Rd0a34c15f3f74da6"/>
+    <p:sldId xmlns:r="http://schemas.openxmlformats.org/officeDocument/2006/relationships" id="259" r:id="Rf4b16f4b66d84832"/>
+    <p:sldId xmlns:r="http://schemas.openxmlformats.org/officeDocument/2006/relationships" id="260" r:id="R731c746232ef48cd"/>
+    <p:sldId xmlns:r="http://schemas.openxmlformats.org/officeDocument/2006/relationships" id="261" r:id="Rc5606795cdef4944"/>
+    <p:sldId xmlns:r="http://schemas.openxmlformats.org/officeDocument/2006/relationships" id="262" r:id="Rda1b86a3ff9d4ecb"/>
+    <p:sldId xmlns:r="http://schemas.openxmlformats.org/officeDocument/2006/relationships" id="263" r:id="R77fd46cf86834cc2"/>
+    <p:sldId xmlns:r="http://schemas.openxmlformats.org/officeDocument/2006/relationships" id="264" r:id="R1f79c3f175d54be0"/>
+    <p:sldId xmlns:r="http://schemas.openxmlformats.org/officeDocument/2006/relationships" id="265" r:id="Ra59078b789ab4d89"/>
+    <p:sldId xmlns:r="http://schemas.openxmlformats.org/officeDocument/2006/relationships" id="266" r:id="R52bb7b2cb5ec48ad"/>
   </p:sldIdLst>
   <p:sldSz cx="12192000" cy="6858000"/>
   <p:notesSz cx="6858000" cy="9144000"/>
@@ -1225,7 +1225,7 @@
   </p:cSld>
   <p:clrMap bg1="lt1" tx1="dk1" bg2="lt2" tx2="dk2" accent1="accent1" accent2="accent2" accent3="accent3" accent4="accent4" accent5="accent5" accent6="accent6" hlink="hlink" folHlink="folHlink"/>
   <p:sldLayoutIdLst>
-    <p:sldLayoutId xmlns:r="http://schemas.openxmlformats.org/officeDocument/2006/relationships" id="2147483649" r:id="Ra73a321fc4a84eeb"/>
+    <p:sldLayoutId xmlns:r="http://schemas.openxmlformats.org/officeDocument/2006/relationships" id="2147483649" r:id="Rd7e0a293b1ef4f74"/>
   </p:sldLayoutIdLst>
   <p:txStyles>
     <p:titleStyle>
@@ -1864,6 +1864,7 @@
           <a:lstStyle xmlns:a="http://schemas.openxmlformats.org/drawingml/2006/main"/>
           <a:p xmlns:a="http://schemas.openxmlformats.org/drawingml/2006/main">
             <a:pPr algn="l">
+              <a:buNone/>
               <a:defRPr sz="825" b="1">
                 <a:solidFill>
                   <a:srgbClr val="5D6673"/>
@@ -1928,6 +1929,7 @@
           <a:lstStyle xmlns:a="http://schemas.openxmlformats.org/drawingml/2006/main"/>
           <a:p xmlns:a="http://schemas.openxmlformats.org/drawingml/2006/main">
             <a:pPr algn="r">
+              <a:buNone/>
               <a:defRPr sz="1125" b="1">
                 <a:solidFill>
                   <a:srgbClr val="5D6673"/>
@@ -2027,6 +2029,7 @@
           <a:lstStyle xmlns:a="http://schemas.openxmlformats.org/drawingml/2006/main"/>
           <a:p xmlns:a="http://schemas.openxmlformats.org/drawingml/2006/main">
             <a:pPr algn="l">
+              <a:buNone/>
               <a:defRPr sz="975" b="1">
                 <a:solidFill>
                   <a:srgbClr val="168A8A"/>
@@ -2091,6 +2094,7 @@
           <a:lstStyle xmlns:a="http://schemas.openxmlformats.org/drawingml/2006/main"/>
           <a:p xmlns:a="http://schemas.openxmlformats.org/drawingml/2006/main">
             <a:pPr algn="l">
+              <a:buNone/>
               <a:defRPr sz="3750" b="1">
                 <a:solidFill>
                   <a:srgbClr val="17202A"/>
@@ -2155,6 +2159,7 @@
           <a:lstStyle xmlns:a="http://schemas.openxmlformats.org/drawingml/2006/main"/>
           <a:p xmlns:a="http://schemas.openxmlformats.org/drawingml/2006/main">
             <a:pPr algn="l">
+              <a:buNone/>
               <a:defRPr sz="1800" b="1">
                 <a:solidFill>
                   <a:srgbClr val="17202A"/>
@@ -2219,6 +2224,7 @@
           <a:lstStyle xmlns:a="http://schemas.openxmlformats.org/drawingml/2006/main"/>
           <a:p xmlns:a="http://schemas.openxmlformats.org/drawingml/2006/main">
             <a:pPr algn="l">
+              <a:buNone/>
               <a:defRPr sz="1350" b="0">
                 <a:solidFill>
                   <a:srgbClr val="5D6673"/>
@@ -2316,6 +2322,7 @@
           <a:lstStyle xmlns:a="http://schemas.openxmlformats.org/drawingml/2006/main"/>
           <a:p xmlns:a="http://schemas.openxmlformats.org/drawingml/2006/main">
             <a:pPr algn="ctr">
+              <a:buNone/>
               <a:defRPr sz="900" b="1">
                 <a:solidFill>
                   <a:srgbClr val="2F8F46"/>
@@ -2413,6 +2420,7 @@
           <a:lstStyle xmlns:a="http://schemas.openxmlformats.org/drawingml/2006/main"/>
           <a:p xmlns:a="http://schemas.openxmlformats.org/drawingml/2006/main">
             <a:pPr algn="ctr">
+              <a:buNone/>
               <a:defRPr sz="900" b="1">
                 <a:solidFill>
                   <a:srgbClr val="168A8A"/>
@@ -2510,6 +2518,7 @@
           <a:lstStyle xmlns:a="http://schemas.openxmlformats.org/drawingml/2006/main"/>
           <a:p xmlns:a="http://schemas.openxmlformats.org/drawingml/2006/main">
             <a:pPr algn="ctr">
+              <a:buNone/>
               <a:defRPr sz="900" b="1">
                 <a:solidFill>
                   <a:srgbClr val="215AA6"/>
@@ -2607,6 +2616,7 @@
           <a:lstStyle xmlns:a="http://schemas.openxmlformats.org/drawingml/2006/main"/>
           <a:p xmlns:a="http://schemas.openxmlformats.org/drawingml/2006/main">
             <a:pPr algn="ctr">
+              <a:buNone/>
               <a:defRPr sz="900" b="1">
                 <a:solidFill>
                   <a:srgbClr val="C57A16"/>
@@ -2671,6 +2681,7 @@
           <a:lstStyle xmlns:a="http://schemas.openxmlformats.org/drawingml/2006/main"/>
           <a:p xmlns:a="http://schemas.openxmlformats.org/drawingml/2006/main">
             <a:pPr algn="l">
+              <a:buNone/>
               <a:defRPr sz="3900" b="1">
                 <a:solidFill>
                   <a:srgbClr val="215AA6"/>
@@ -2689,7 +2700,7 @@
                 <a:ea typeface="Aptos Display"/>
                 <a:cs typeface="Aptos Display"/>
               </a:rPr>
-              <a:t>0.7619</a:t>
+              <a:t>0.7644</a:t>
             </a:r>
           </a:p>
         </p:txBody>
@@ -2735,6 +2746,7 @@
           <a:lstStyle xmlns:a="http://schemas.openxmlformats.org/drawingml/2006/main"/>
           <a:p xmlns:a="http://schemas.openxmlformats.org/drawingml/2006/main">
             <a:pPr algn="l">
+              <a:buNone/>
               <a:defRPr sz="1125" b="0">
                 <a:solidFill>
                   <a:srgbClr val="5D6673"/>
@@ -2753,7 +2765,7 @@
                 <a:ea typeface="Aptos"/>
                 <a:cs typeface="Aptos"/>
               </a:rPr>
-              <a:t>fresh validation ROC-AUC</a:t>
+              <a:t>final test ROC-AUC</a:t>
             </a:r>
           </a:p>
         </p:txBody>
@@ -2799,6 +2811,7 @@
           <a:lstStyle xmlns:a="http://schemas.openxmlformats.org/drawingml/2006/main"/>
           <a:p xmlns:a="http://schemas.openxmlformats.org/drawingml/2006/main">
             <a:pPr algn="l">
+              <a:buNone/>
               <a:defRPr sz="3900" b="1">
                 <a:solidFill>
                   <a:srgbClr val="2F8F46"/>
@@ -2863,6 +2876,7 @@
           <a:lstStyle xmlns:a="http://schemas.openxmlformats.org/drawingml/2006/main"/>
           <a:p xmlns:a="http://schemas.openxmlformats.org/drawingml/2006/main">
             <a:pPr algn="l">
+              <a:buNone/>
               <a:defRPr sz="1125" b="0">
                 <a:solidFill>
                   <a:srgbClr val="5D6673"/>
@@ -2927,6 +2941,7 @@
           <a:lstStyle xmlns:a="http://schemas.openxmlformats.org/drawingml/2006/main"/>
           <a:p xmlns:a="http://schemas.openxmlformats.org/drawingml/2006/main">
             <a:pPr algn="l">
+              <a:buNone/>
               <a:defRPr sz="3900" b="1">
                 <a:solidFill>
                   <a:srgbClr val="168A8A"/>
@@ -2991,6 +3006,7 @@
           <a:lstStyle xmlns:a="http://schemas.openxmlformats.org/drawingml/2006/main"/>
           <a:p xmlns:a="http://schemas.openxmlformats.org/drawingml/2006/main">
             <a:pPr algn="l">
+              <a:buNone/>
               <a:defRPr sz="1125" b="0">
                 <a:solidFill>
                   <a:srgbClr val="5D6673"/>
@@ -3055,6 +3071,7 @@
           <a:lstStyle xmlns:a="http://schemas.openxmlformats.org/drawingml/2006/main"/>
           <a:p xmlns:a="http://schemas.openxmlformats.org/drawingml/2006/main">
             <a:pPr algn="l">
+              <a:buNone/>
               <a:defRPr sz="3900" b="1">
                 <a:solidFill>
                   <a:srgbClr val="C57A16"/>
@@ -3119,6 +3136,7 @@
           <a:lstStyle xmlns:a="http://schemas.openxmlformats.org/drawingml/2006/main"/>
           <a:p xmlns:a="http://schemas.openxmlformats.org/drawingml/2006/main">
             <a:pPr algn="l">
+              <a:buNone/>
               <a:defRPr sz="1125" b="0">
                 <a:solidFill>
                   <a:srgbClr val="5D6673"/>
@@ -3137,7 +3155,7 @@
                 <a:ea typeface="Aptos"/>
                 <a:cs typeface="Aptos"/>
               </a:rPr>
-              <a:t>sampled MLflow run</a:t>
+              <a:t>sampled final-eval run</a:t>
             </a:r>
           </a:p>
         </p:txBody>
@@ -3183,6 +3201,7 @@
           <a:lstStyle xmlns:a="http://schemas.openxmlformats.org/drawingml/2006/main"/>
           <a:p xmlns:a="http://schemas.openxmlformats.org/drawingml/2006/main">
             <a:pPr algn="l">
+              <a:buNone/>
               <a:defRPr sz="750" b="0">
                 <a:solidFill>
                   <a:srgbClr val="5D6673"/>
@@ -3374,6 +3393,7 @@
           <a:lstStyle xmlns:a="http://schemas.openxmlformats.org/drawingml/2006/main"/>
           <a:p xmlns:a="http://schemas.openxmlformats.org/drawingml/2006/main">
             <a:pPr algn="l">
+              <a:buNone/>
               <a:defRPr sz="825" b="1">
                 <a:solidFill>
                   <a:srgbClr val="5D6673"/>
@@ -3438,6 +3458,7 @@
           <a:lstStyle xmlns:a="http://schemas.openxmlformats.org/drawingml/2006/main"/>
           <a:p xmlns:a="http://schemas.openxmlformats.org/drawingml/2006/main">
             <a:pPr algn="r">
+              <a:buNone/>
               <a:defRPr sz="1125" b="1">
                 <a:solidFill>
                   <a:srgbClr val="5D6673"/>
@@ -3537,6 +3558,7 @@
           <a:lstStyle xmlns:a="http://schemas.openxmlformats.org/drawingml/2006/main"/>
           <a:p xmlns:a="http://schemas.openxmlformats.org/drawingml/2006/main">
             <a:pPr algn="l">
+              <a:buNone/>
               <a:defRPr sz="975" b="1">
                 <a:solidFill>
                   <a:srgbClr val="168A8A"/>
@@ -3601,6 +3623,7 @@
           <a:lstStyle xmlns:a="http://schemas.openxmlformats.org/drawingml/2006/main"/>
           <a:p xmlns:a="http://schemas.openxmlformats.org/drawingml/2006/main">
             <a:pPr algn="l">
+              <a:buNone/>
               <a:defRPr sz="3225" b="1">
                 <a:solidFill>
                   <a:srgbClr val="17202A"/>
@@ -3626,14 +3649,14 @@
       </p:sp>
       <p:pic>
         <p:nvPicPr>
-          <p:cNvPr id="9" name=""/>
+          <p:cNvPr id="28" name=""/>
           <p:cNvPicPr>
             <a:picLocks xmlns:a="http://schemas.openxmlformats.org/drawingml/2006/main" noChangeAspect="1"/>
           </p:cNvPicPr>
           <p:nvPr/>
         </p:nvPicPr>
         <p:blipFill>
-          <a:blip xmlns:r="http://schemas.openxmlformats.org/officeDocument/2006/relationships" xmlns:a="http://schemas.openxmlformats.org/drawingml/2006/main" r:embed="R257b562560b84a54"/>
+          <a:blip xmlns:r="http://schemas.openxmlformats.org/officeDocument/2006/relationships" xmlns:a="http://schemas.openxmlformats.org/drawingml/2006/main" r:embed="R5189185580654d7a"/>
           <a:stretch xmlns:a="http://schemas.openxmlformats.org/drawingml/2006/main"/>
         </p:blipFill>
         <p:spPr>
@@ -3687,6 +3710,7 @@
           <a:lstStyle xmlns:a="http://schemas.openxmlformats.org/drawingml/2006/main"/>
           <a:p xmlns:a="http://schemas.openxmlformats.org/drawingml/2006/main">
             <a:pPr algn="l">
+              <a:buNone/>
               <a:defRPr sz="2250" b="1">
                 <a:solidFill>
                   <a:srgbClr val="215AA6"/>
@@ -3751,6 +3775,7 @@
           <a:lstStyle xmlns:a="http://schemas.openxmlformats.org/drawingml/2006/main"/>
           <a:p xmlns:a="http://schemas.openxmlformats.org/drawingml/2006/main">
             <a:pPr algn="l">
+              <a:buNone/>
               <a:defRPr sz="1500" b="0">
                 <a:solidFill>
                   <a:srgbClr val="17202A"/>
@@ -3815,6 +3840,7 @@
           <a:lstStyle xmlns:a="http://schemas.openxmlformats.org/drawingml/2006/main"/>
           <a:p xmlns:a="http://schemas.openxmlformats.org/drawingml/2006/main">
             <a:pPr algn="l">
+              <a:buNone/>
               <a:defRPr sz="2250" b="1">
                 <a:solidFill>
                   <a:srgbClr val="168A8A"/>
@@ -3879,6 +3905,7 @@
           <a:lstStyle xmlns:a="http://schemas.openxmlformats.org/drawingml/2006/main"/>
           <a:p xmlns:a="http://schemas.openxmlformats.org/drawingml/2006/main">
             <a:pPr algn="l">
+              <a:buNone/>
               <a:defRPr sz="1500" b="0">
                 <a:solidFill>
                   <a:srgbClr val="17202A"/>
@@ -3943,6 +3970,7 @@
           <a:lstStyle xmlns:a="http://schemas.openxmlformats.org/drawingml/2006/main"/>
           <a:p xmlns:a="http://schemas.openxmlformats.org/drawingml/2006/main">
             <a:pPr algn="l">
+              <a:buNone/>
               <a:defRPr sz="2250" b="1">
                 <a:solidFill>
                   <a:srgbClr val="2F8F46"/>
@@ -4007,6 +4035,7 @@
           <a:lstStyle xmlns:a="http://schemas.openxmlformats.org/drawingml/2006/main"/>
           <a:p xmlns:a="http://schemas.openxmlformats.org/drawingml/2006/main">
             <a:pPr algn="l">
+              <a:buNone/>
               <a:defRPr sz="1500" b="0">
                 <a:solidFill>
                   <a:srgbClr val="17202A"/>
@@ -4071,6 +4100,7 @@
           <a:lstStyle xmlns:a="http://schemas.openxmlformats.org/drawingml/2006/main"/>
           <a:p xmlns:a="http://schemas.openxmlformats.org/drawingml/2006/main">
             <a:pPr algn="l">
+              <a:buNone/>
               <a:defRPr sz="2250" b="1">
                 <a:solidFill>
                   <a:srgbClr val="C57A16"/>
@@ -4135,6 +4165,7 @@
           <a:lstStyle xmlns:a="http://schemas.openxmlformats.org/drawingml/2006/main"/>
           <a:p xmlns:a="http://schemas.openxmlformats.org/drawingml/2006/main">
             <a:pPr algn="l">
+              <a:buNone/>
               <a:defRPr sz="1500" b="0">
                 <a:solidFill>
                   <a:srgbClr val="17202A"/>
@@ -4199,6 +4230,7 @@
           <a:lstStyle xmlns:a="http://schemas.openxmlformats.org/drawingml/2006/main"/>
           <a:p xmlns:a="http://schemas.openxmlformats.org/drawingml/2006/main">
             <a:pPr algn="l">
+              <a:buNone/>
               <a:defRPr sz="750" b="0">
                 <a:solidFill>
                   <a:srgbClr val="5D6673"/>
@@ -4390,6 +4422,7 @@
           <a:lstStyle xmlns:a="http://schemas.openxmlformats.org/drawingml/2006/main"/>
           <a:p xmlns:a="http://schemas.openxmlformats.org/drawingml/2006/main">
             <a:pPr algn="l">
+              <a:buNone/>
               <a:defRPr sz="825" b="1">
                 <a:solidFill>
                   <a:srgbClr val="5D6673"/>
@@ -4454,6 +4487,7 @@
           <a:lstStyle xmlns:a="http://schemas.openxmlformats.org/drawingml/2006/main"/>
           <a:p xmlns:a="http://schemas.openxmlformats.org/drawingml/2006/main">
             <a:pPr algn="r">
+              <a:buNone/>
               <a:defRPr sz="1125" b="1">
                 <a:solidFill>
                   <a:srgbClr val="5D6673"/>
@@ -4553,6 +4587,7 @@
           <a:lstStyle xmlns:a="http://schemas.openxmlformats.org/drawingml/2006/main"/>
           <a:p xmlns:a="http://schemas.openxmlformats.org/drawingml/2006/main">
             <a:pPr algn="l">
+              <a:buNone/>
               <a:defRPr sz="975" b="1">
                 <a:solidFill>
                   <a:srgbClr val="168A8A"/>
@@ -4617,6 +4652,7 @@
           <a:lstStyle xmlns:a="http://schemas.openxmlformats.org/drawingml/2006/main"/>
           <a:p xmlns:a="http://schemas.openxmlformats.org/drawingml/2006/main">
             <a:pPr algn="l">
+              <a:buNone/>
               <a:defRPr sz="3225" b="1">
                 <a:solidFill>
                   <a:srgbClr val="17202A"/>
@@ -4681,6 +4717,7 @@
           <a:lstStyle xmlns:a="http://schemas.openxmlformats.org/drawingml/2006/main"/>
           <a:p xmlns:a="http://schemas.openxmlformats.org/drawingml/2006/main">
             <a:pPr algn="l">
+              <a:buNone/>
               <a:defRPr sz="3900" b="1">
                 <a:solidFill>
                   <a:srgbClr val="215AA6"/>
@@ -4745,6 +4782,7 @@
           <a:lstStyle xmlns:a="http://schemas.openxmlformats.org/drawingml/2006/main"/>
           <a:p xmlns:a="http://schemas.openxmlformats.org/drawingml/2006/main">
             <a:pPr algn="l">
+              <a:buNone/>
               <a:defRPr sz="1125" b="0">
                 <a:solidFill>
                   <a:srgbClr val="5D6673"/>
@@ -4809,6 +4847,7 @@
           <a:lstStyle xmlns:a="http://schemas.openxmlformats.org/drawingml/2006/main"/>
           <a:p xmlns:a="http://schemas.openxmlformats.org/drawingml/2006/main">
             <a:pPr algn="l">
+              <a:buNone/>
               <a:defRPr sz="3900" b="1">
                 <a:solidFill>
                   <a:srgbClr val="2F8F46"/>
@@ -4873,6 +4912,7 @@
           <a:lstStyle xmlns:a="http://schemas.openxmlformats.org/drawingml/2006/main"/>
           <a:p xmlns:a="http://schemas.openxmlformats.org/drawingml/2006/main">
             <a:pPr algn="l">
+              <a:buNone/>
               <a:defRPr sz="1125" b="0">
                 <a:solidFill>
                   <a:srgbClr val="5D6673"/>
@@ -4937,6 +4977,7 @@
           <a:lstStyle xmlns:a="http://schemas.openxmlformats.org/drawingml/2006/main"/>
           <a:p xmlns:a="http://schemas.openxmlformats.org/drawingml/2006/main">
             <a:pPr algn="l">
+              <a:buNone/>
               <a:defRPr sz="3900" b="1">
                 <a:solidFill>
                   <a:srgbClr val="C57A16"/>
@@ -5001,6 +5042,7 @@
           <a:lstStyle xmlns:a="http://schemas.openxmlformats.org/drawingml/2006/main"/>
           <a:p xmlns:a="http://schemas.openxmlformats.org/drawingml/2006/main">
             <a:pPr algn="l">
+              <a:buNone/>
               <a:defRPr sz="1125" b="0">
                 <a:solidFill>
                   <a:srgbClr val="5D6673"/>
@@ -5100,6 +5142,7 @@
           <a:lstStyle xmlns:a="http://schemas.openxmlformats.org/drawingml/2006/main"/>
           <a:p xmlns:a="http://schemas.openxmlformats.org/drawingml/2006/main">
             <a:pPr algn="l">
+              <a:buNone/>
               <a:defRPr sz="1350" b="0">
                 <a:solidFill>
                   <a:srgbClr val="17202A"/>
@@ -5118,7 +5161,7 @@
                 <a:ea typeface="Aptos"/>
                 <a:cs typeface="Aptos"/>
               </a:rPr>
-              <a:t>Recommendation: present 0.7619 as the fresh validation run and 0.7679 as tuning evidence.</a:t>
+              <a:t>Recommendation: present 0.7644 as final test ROC-AUC, with 0.7619 validation ROC-AUC and 0.7679 tuning evidence.</a:t>
             </a:r>
           </a:p>
         </p:txBody>
@@ -5199,6 +5242,7 @@
           <a:lstStyle xmlns:a="http://schemas.openxmlformats.org/drawingml/2006/main"/>
           <a:p xmlns:a="http://schemas.openxmlformats.org/drawingml/2006/main">
             <a:pPr algn="l">
+              <a:buNone/>
               <a:defRPr sz="1350" b="0">
                 <a:solidFill>
                   <a:srgbClr val="17202A"/>
@@ -5263,6 +5307,7 @@
           <a:lstStyle xmlns:a="http://schemas.openxmlformats.org/drawingml/2006/main"/>
           <a:p xmlns:a="http://schemas.openxmlformats.org/drawingml/2006/main">
             <a:pPr algn="l">
+              <a:buNone/>
               <a:defRPr sz="1575" b="1">
                 <a:solidFill>
                   <a:srgbClr val="17202A"/>
@@ -5327,6 +5372,7 @@
           <a:lstStyle xmlns:a="http://schemas.openxmlformats.org/drawingml/2006/main"/>
           <a:p xmlns:a="http://schemas.openxmlformats.org/drawingml/2006/main">
             <a:pPr algn="l">
+              <a:buNone/>
               <a:defRPr sz="750" b="0">
                 <a:solidFill>
                   <a:srgbClr val="5D6673"/>
@@ -5518,6 +5564,7 @@
           <a:lstStyle xmlns:a="http://schemas.openxmlformats.org/drawingml/2006/main"/>
           <a:p xmlns:a="http://schemas.openxmlformats.org/drawingml/2006/main">
             <a:pPr algn="l">
+              <a:buNone/>
               <a:defRPr sz="825" b="1">
                 <a:solidFill>
                   <a:srgbClr val="5D6673"/>
@@ -5582,6 +5629,7 @@
           <a:lstStyle xmlns:a="http://schemas.openxmlformats.org/drawingml/2006/main"/>
           <a:p xmlns:a="http://schemas.openxmlformats.org/drawingml/2006/main">
             <a:pPr algn="r">
+              <a:buNone/>
               <a:defRPr sz="1125" b="1">
                 <a:solidFill>
                   <a:srgbClr val="5D6673"/>
@@ -5681,6 +5729,7 @@
           <a:lstStyle xmlns:a="http://schemas.openxmlformats.org/drawingml/2006/main"/>
           <a:p xmlns:a="http://schemas.openxmlformats.org/drawingml/2006/main">
             <a:pPr algn="l">
+              <a:buNone/>
               <a:defRPr sz="975" b="1">
                 <a:solidFill>
                   <a:srgbClr val="168A8A"/>
@@ -5745,6 +5794,7 @@
           <a:lstStyle xmlns:a="http://schemas.openxmlformats.org/drawingml/2006/main"/>
           <a:p xmlns:a="http://schemas.openxmlformats.org/drawingml/2006/main">
             <a:pPr algn="l">
+              <a:buNone/>
               <a:defRPr sz="3225" b="1">
                 <a:solidFill>
                   <a:srgbClr val="17202A"/>
@@ -5842,6 +5892,7 @@
           <a:lstStyle xmlns:a="http://schemas.openxmlformats.org/drawingml/2006/main"/>
           <a:p xmlns:a="http://schemas.openxmlformats.org/drawingml/2006/main">
             <a:pPr algn="l">
+              <a:buNone/>
               <a:defRPr sz="1575" b="1">
                 <a:solidFill>
                   <a:srgbClr val="17202A"/>
@@ -5906,6 +5957,7 @@
           <a:lstStyle xmlns:a="http://schemas.openxmlformats.org/drawingml/2006/main"/>
           <a:p xmlns:a="http://schemas.openxmlformats.org/drawingml/2006/main">
             <a:pPr algn="l">
+              <a:buNone/>
               <a:defRPr sz="1125" b="0">
                 <a:solidFill>
                   <a:srgbClr val="5D6673"/>
@@ -6003,6 +6055,7 @@
           <a:lstStyle xmlns:a="http://schemas.openxmlformats.org/drawingml/2006/main"/>
           <a:p xmlns:a="http://schemas.openxmlformats.org/drawingml/2006/main">
             <a:pPr algn="l">
+              <a:buNone/>
               <a:defRPr sz="1575" b="1">
                 <a:solidFill>
                   <a:srgbClr val="17202A"/>
@@ -6067,6 +6120,7 @@
           <a:lstStyle xmlns:a="http://schemas.openxmlformats.org/drawingml/2006/main"/>
           <a:p xmlns:a="http://schemas.openxmlformats.org/drawingml/2006/main">
             <a:pPr algn="l">
+              <a:buNone/>
               <a:defRPr sz="1125" b="0">
                 <a:solidFill>
                   <a:srgbClr val="5D6673"/>
@@ -6164,6 +6218,7 @@
           <a:lstStyle xmlns:a="http://schemas.openxmlformats.org/drawingml/2006/main"/>
           <a:p xmlns:a="http://schemas.openxmlformats.org/drawingml/2006/main">
             <a:pPr algn="l">
+              <a:buNone/>
               <a:defRPr sz="1575" b="1">
                 <a:solidFill>
                   <a:srgbClr val="17202A"/>
@@ -6228,6 +6283,7 @@
           <a:lstStyle xmlns:a="http://schemas.openxmlformats.org/drawingml/2006/main"/>
           <a:p xmlns:a="http://schemas.openxmlformats.org/drawingml/2006/main">
             <a:pPr algn="l">
+              <a:buNone/>
               <a:defRPr sz="1125" b="0">
                 <a:solidFill>
                   <a:srgbClr val="5D6673"/>
@@ -6325,6 +6381,7 @@
           <a:lstStyle xmlns:a="http://schemas.openxmlformats.org/drawingml/2006/main"/>
           <a:p xmlns:a="http://schemas.openxmlformats.org/drawingml/2006/main">
             <a:pPr algn="l">
+              <a:buNone/>
               <a:defRPr sz="1575" b="1">
                 <a:solidFill>
                   <a:srgbClr val="17202A"/>
@@ -6389,6 +6446,7 @@
           <a:lstStyle xmlns:a="http://schemas.openxmlformats.org/drawingml/2006/main"/>
           <a:p xmlns:a="http://schemas.openxmlformats.org/drawingml/2006/main">
             <a:pPr algn="l">
+              <a:buNone/>
               <a:defRPr sz="1125" b="0">
                 <a:solidFill>
                   <a:srgbClr val="5D6673"/>
@@ -6486,6 +6544,7 @@
           <a:lstStyle xmlns:a="http://schemas.openxmlformats.org/drawingml/2006/main"/>
           <a:p xmlns:a="http://schemas.openxmlformats.org/drawingml/2006/main">
             <a:pPr algn="l">
+              <a:buNone/>
               <a:defRPr sz="1575" b="1">
                 <a:solidFill>
                   <a:srgbClr val="17202A"/>
@@ -6550,6 +6609,7 @@
           <a:lstStyle xmlns:a="http://schemas.openxmlformats.org/drawingml/2006/main"/>
           <a:p xmlns:a="http://schemas.openxmlformats.org/drawingml/2006/main">
             <a:pPr algn="l">
+              <a:buNone/>
               <a:defRPr sz="1125" b="0">
                 <a:solidFill>
                   <a:srgbClr val="5D6673"/>
@@ -6647,6 +6707,7 @@
           <a:lstStyle xmlns:a="http://schemas.openxmlformats.org/drawingml/2006/main"/>
           <a:p xmlns:a="http://schemas.openxmlformats.org/drawingml/2006/main">
             <a:pPr algn="l">
+              <a:buNone/>
               <a:defRPr sz="1575" b="1">
                 <a:solidFill>
                   <a:srgbClr val="17202A"/>
@@ -6711,6 +6772,7 @@
           <a:lstStyle xmlns:a="http://schemas.openxmlformats.org/drawingml/2006/main"/>
           <a:p xmlns:a="http://schemas.openxmlformats.org/drawingml/2006/main">
             <a:pPr algn="l">
+              <a:buNone/>
               <a:defRPr sz="1125" b="0">
                 <a:solidFill>
                   <a:srgbClr val="5D6673"/>
@@ -6808,6 +6870,7 @@
           <a:lstStyle xmlns:a="http://schemas.openxmlformats.org/drawingml/2006/main"/>
           <a:p xmlns:a="http://schemas.openxmlformats.org/drawingml/2006/main">
             <a:pPr algn="ctr">
+              <a:buNone/>
               <a:defRPr sz="900" b="1">
                 <a:solidFill>
                   <a:srgbClr val="168A8A"/>
@@ -6872,6 +6935,7 @@
           <a:lstStyle xmlns:a="http://schemas.openxmlformats.org/drawingml/2006/main"/>
           <a:p xmlns:a="http://schemas.openxmlformats.org/drawingml/2006/main">
             <a:pPr algn="l">
+              <a:buNone/>
               <a:defRPr sz="1650" b="1">
                 <a:solidFill>
                   <a:srgbClr val="17202A"/>
@@ -6936,6 +7000,7 @@
           <a:lstStyle xmlns:a="http://schemas.openxmlformats.org/drawingml/2006/main"/>
           <a:p xmlns:a="http://schemas.openxmlformats.org/drawingml/2006/main">
             <a:pPr algn="l">
+              <a:buNone/>
               <a:defRPr sz="750" b="0">
                 <a:solidFill>
                   <a:srgbClr val="5D6673"/>
@@ -7127,6 +7192,7 @@
           <a:lstStyle xmlns:a="http://schemas.openxmlformats.org/drawingml/2006/main"/>
           <a:p xmlns:a="http://schemas.openxmlformats.org/drawingml/2006/main">
             <a:pPr algn="l">
+              <a:buNone/>
               <a:defRPr sz="825" b="1">
                 <a:solidFill>
                   <a:srgbClr val="5D6673"/>
@@ -7191,6 +7257,7 @@
           <a:lstStyle xmlns:a="http://schemas.openxmlformats.org/drawingml/2006/main"/>
           <a:p xmlns:a="http://schemas.openxmlformats.org/drawingml/2006/main">
             <a:pPr algn="r">
+              <a:buNone/>
               <a:defRPr sz="1125" b="1">
                 <a:solidFill>
                   <a:srgbClr val="5D6673"/>
@@ -7290,6 +7357,7 @@
           <a:lstStyle xmlns:a="http://schemas.openxmlformats.org/drawingml/2006/main"/>
           <a:p xmlns:a="http://schemas.openxmlformats.org/drawingml/2006/main">
             <a:pPr algn="l">
+              <a:buNone/>
               <a:defRPr sz="975" b="1">
                 <a:solidFill>
                   <a:srgbClr val="168A8A"/>
@@ -7354,6 +7422,7 @@
           <a:lstStyle xmlns:a="http://schemas.openxmlformats.org/drawingml/2006/main"/>
           <a:p xmlns:a="http://schemas.openxmlformats.org/drawingml/2006/main">
             <a:pPr algn="l">
+              <a:buNone/>
               <a:defRPr sz="3225" b="1">
                 <a:solidFill>
                   <a:srgbClr val="17202A"/>
@@ -7418,6 +7487,7 @@
           <a:lstStyle xmlns:a="http://schemas.openxmlformats.org/drawingml/2006/main"/>
           <a:p xmlns:a="http://schemas.openxmlformats.org/drawingml/2006/main">
             <a:pPr algn="l">
+              <a:buNone/>
               <a:defRPr sz="3900" b="1">
                 <a:solidFill>
                   <a:srgbClr val="BF5B49"/>
@@ -7482,6 +7552,7 @@
           <a:lstStyle xmlns:a="http://schemas.openxmlformats.org/drawingml/2006/main"/>
           <a:p xmlns:a="http://schemas.openxmlformats.org/drawingml/2006/main">
             <a:pPr algn="l">
+              <a:buNone/>
               <a:defRPr sz="1125" b="0">
                 <a:solidFill>
                   <a:srgbClr val="5D6673"/>
@@ -7546,6 +7617,7 @@
           <a:lstStyle xmlns:a="http://schemas.openxmlformats.org/drawingml/2006/main"/>
           <a:p xmlns:a="http://schemas.openxmlformats.org/drawingml/2006/main">
             <a:pPr algn="l">
+              <a:buNone/>
               <a:defRPr sz="3900" b="1">
                 <a:solidFill>
                   <a:srgbClr val="215AA6"/>
@@ -7610,6 +7682,7 @@
           <a:lstStyle xmlns:a="http://schemas.openxmlformats.org/drawingml/2006/main"/>
           <a:p xmlns:a="http://schemas.openxmlformats.org/drawingml/2006/main">
             <a:pPr algn="l">
+              <a:buNone/>
               <a:defRPr sz="1125" b="0">
                 <a:solidFill>
                   <a:srgbClr val="5D6673"/>
@@ -7674,6 +7747,7 @@
           <a:lstStyle xmlns:a="http://schemas.openxmlformats.org/drawingml/2006/main"/>
           <a:p xmlns:a="http://schemas.openxmlformats.org/drawingml/2006/main">
             <a:pPr algn="l">
+              <a:buNone/>
               <a:defRPr sz="3900" b="1">
                 <a:solidFill>
                   <a:srgbClr val="168A8A"/>
@@ -7738,6 +7812,7 @@
           <a:lstStyle xmlns:a="http://schemas.openxmlformats.org/drawingml/2006/main"/>
           <a:p xmlns:a="http://schemas.openxmlformats.org/drawingml/2006/main">
             <a:pPr algn="l">
+              <a:buNone/>
               <a:defRPr sz="1125" b="0">
                 <a:solidFill>
                   <a:srgbClr val="5D6673"/>
@@ -7870,6 +7945,7 @@
           <a:lstStyle xmlns:a="http://schemas.openxmlformats.org/drawingml/2006/main"/>
           <a:p xmlns:a="http://schemas.openxmlformats.org/drawingml/2006/main">
             <a:pPr algn="l">
+              <a:buNone/>
               <a:defRPr sz="1350" b="0">
                 <a:solidFill>
                   <a:srgbClr val="17202A"/>
@@ -7969,6 +8045,7 @@
           <a:lstStyle xmlns:a="http://schemas.openxmlformats.org/drawingml/2006/main"/>
           <a:p xmlns:a="http://schemas.openxmlformats.org/drawingml/2006/main">
             <a:pPr algn="l">
+              <a:buNone/>
               <a:defRPr sz="1350" b="0">
                 <a:solidFill>
                   <a:srgbClr val="17202A"/>
@@ -8033,6 +8110,7 @@
           <a:lstStyle xmlns:a="http://schemas.openxmlformats.org/drawingml/2006/main"/>
           <a:p xmlns:a="http://schemas.openxmlformats.org/drawingml/2006/main">
             <a:pPr algn="l">
+              <a:buNone/>
               <a:defRPr sz="750" b="0">
                 <a:solidFill>
                   <a:srgbClr val="5D6673"/>
@@ -8224,6 +8302,7 @@
           <a:lstStyle xmlns:a="http://schemas.openxmlformats.org/drawingml/2006/main"/>
           <a:p xmlns:a="http://schemas.openxmlformats.org/drawingml/2006/main">
             <a:pPr algn="l">
+              <a:buNone/>
               <a:defRPr sz="825" b="1">
                 <a:solidFill>
                   <a:srgbClr val="5D6673"/>
@@ -8288,6 +8367,7 @@
           <a:lstStyle xmlns:a="http://schemas.openxmlformats.org/drawingml/2006/main"/>
           <a:p xmlns:a="http://schemas.openxmlformats.org/drawingml/2006/main">
             <a:pPr algn="r">
+              <a:buNone/>
               <a:defRPr sz="1125" b="1">
                 <a:solidFill>
                   <a:srgbClr val="5D6673"/>
@@ -8387,6 +8467,7 @@
           <a:lstStyle xmlns:a="http://schemas.openxmlformats.org/drawingml/2006/main"/>
           <a:p xmlns:a="http://schemas.openxmlformats.org/drawingml/2006/main">
             <a:pPr algn="l">
+              <a:buNone/>
               <a:defRPr sz="975" b="1">
                 <a:solidFill>
                   <a:srgbClr val="168A8A"/>
@@ -8451,6 +8532,7 @@
           <a:lstStyle xmlns:a="http://schemas.openxmlformats.org/drawingml/2006/main"/>
           <a:p xmlns:a="http://schemas.openxmlformats.org/drawingml/2006/main">
             <a:pPr algn="l">
+              <a:buNone/>
               <a:defRPr sz="3150" b="1">
                 <a:solidFill>
                   <a:srgbClr val="17202A"/>
@@ -8581,6 +8663,7 @@
           <a:lstStyle xmlns:a="http://schemas.openxmlformats.org/drawingml/2006/main"/>
           <a:p xmlns:a="http://schemas.openxmlformats.org/drawingml/2006/main">
             <a:pPr algn="l">
+              <a:buNone/>
               <a:defRPr sz="2100" b="1">
                 <a:solidFill>
                   <a:srgbClr val="BF5B49"/>
@@ -8645,6 +8728,7 @@
           <a:lstStyle xmlns:a="http://schemas.openxmlformats.org/drawingml/2006/main"/>
           <a:p xmlns:a="http://schemas.openxmlformats.org/drawingml/2006/main">
             <a:pPr algn="l">
+              <a:buNone/>
               <a:defRPr sz="1875" b="1">
                 <a:solidFill>
                   <a:srgbClr val="17202A"/>
@@ -8742,6 +8826,7 @@
           <a:lstStyle xmlns:a="http://schemas.openxmlformats.org/drawingml/2006/main"/>
           <a:p xmlns:a="http://schemas.openxmlformats.org/drawingml/2006/main">
             <a:pPr algn="ctr">
+              <a:buNone/>
               <a:defRPr sz="900" b="1">
                 <a:solidFill>
                   <a:srgbClr val="BF5B49"/>
@@ -8806,6 +8891,7 @@
           <a:lstStyle xmlns:a="http://schemas.openxmlformats.org/drawingml/2006/main"/>
           <a:p xmlns:a="http://schemas.openxmlformats.org/drawingml/2006/main">
             <a:pPr algn="l">
+              <a:buNone/>
               <a:defRPr sz="2100" b="1">
                 <a:solidFill>
                   <a:srgbClr val="2F8F46"/>
@@ -8870,6 +8956,7 @@
           <a:lstStyle xmlns:a="http://schemas.openxmlformats.org/drawingml/2006/main"/>
           <a:p xmlns:a="http://schemas.openxmlformats.org/drawingml/2006/main">
             <a:pPr algn="l">
+              <a:buNone/>
               <a:defRPr sz="1875" b="1">
                 <a:solidFill>
                   <a:srgbClr val="17202A"/>
@@ -8967,6 +9054,7 @@
           <a:lstStyle xmlns:a="http://schemas.openxmlformats.org/drawingml/2006/main"/>
           <a:p xmlns:a="http://schemas.openxmlformats.org/drawingml/2006/main">
             <a:pPr algn="ctr">
+              <a:buNone/>
               <a:defRPr sz="900" b="1">
                 <a:solidFill>
                   <a:srgbClr val="2F8F46"/>
@@ -9031,6 +9119,7 @@
           <a:lstStyle xmlns:a="http://schemas.openxmlformats.org/drawingml/2006/main"/>
           <a:p xmlns:a="http://schemas.openxmlformats.org/drawingml/2006/main">
             <a:pPr algn="l">
+              <a:buNone/>
               <a:defRPr sz="750" b="0">
                 <a:solidFill>
                   <a:srgbClr val="5D6673"/>
@@ -9222,6 +9311,7 @@
           <a:lstStyle xmlns:a="http://schemas.openxmlformats.org/drawingml/2006/main"/>
           <a:p xmlns:a="http://schemas.openxmlformats.org/drawingml/2006/main">
             <a:pPr algn="l">
+              <a:buNone/>
               <a:defRPr sz="825" b="1">
                 <a:solidFill>
                   <a:srgbClr val="5D6673"/>
@@ -9286,6 +9376,7 @@
           <a:lstStyle xmlns:a="http://schemas.openxmlformats.org/drawingml/2006/main"/>
           <a:p xmlns:a="http://schemas.openxmlformats.org/drawingml/2006/main">
             <a:pPr algn="r">
+              <a:buNone/>
               <a:defRPr sz="1125" b="1">
                 <a:solidFill>
                   <a:srgbClr val="5D6673"/>
@@ -9385,6 +9476,7 @@
           <a:lstStyle xmlns:a="http://schemas.openxmlformats.org/drawingml/2006/main"/>
           <a:p xmlns:a="http://schemas.openxmlformats.org/drawingml/2006/main">
             <a:pPr algn="l">
+              <a:buNone/>
               <a:defRPr sz="975" b="1">
                 <a:solidFill>
                   <a:srgbClr val="168A8A"/>
@@ -9449,6 +9541,7 @@
           <a:lstStyle xmlns:a="http://schemas.openxmlformats.org/drawingml/2006/main"/>
           <a:p xmlns:a="http://schemas.openxmlformats.org/drawingml/2006/main">
             <a:pPr algn="l">
+              <a:buNone/>
               <a:defRPr sz="3225" b="1">
                 <a:solidFill>
                   <a:srgbClr val="17202A"/>
@@ -9546,6 +9639,7 @@
           <a:lstStyle xmlns:a="http://schemas.openxmlformats.org/drawingml/2006/main"/>
           <a:p xmlns:a="http://schemas.openxmlformats.org/drawingml/2006/main">
             <a:pPr algn="l">
+              <a:buNone/>
               <a:defRPr sz="2025" b="1">
                 <a:solidFill>
                   <a:srgbClr val="215AA6"/>
@@ -9610,6 +9704,7 @@
           <a:lstStyle xmlns:a="http://schemas.openxmlformats.org/drawingml/2006/main"/>
           <a:p xmlns:a="http://schemas.openxmlformats.org/drawingml/2006/main">
             <a:pPr algn="l">
+              <a:buNone/>
               <a:defRPr sz="1275" b="0">
                 <a:solidFill>
                   <a:srgbClr val="17202A"/>
@@ -9742,6 +9837,7 @@
           <a:lstStyle xmlns:a="http://schemas.openxmlformats.org/drawingml/2006/main"/>
           <a:p xmlns:a="http://schemas.openxmlformats.org/drawingml/2006/main">
             <a:pPr algn="l">
+              <a:buNone/>
               <a:defRPr sz="2025" b="1">
                 <a:solidFill>
                   <a:srgbClr val="168A8A"/>
@@ -9806,6 +9902,7 @@
           <a:lstStyle xmlns:a="http://schemas.openxmlformats.org/drawingml/2006/main"/>
           <a:p xmlns:a="http://schemas.openxmlformats.org/drawingml/2006/main">
             <a:pPr algn="l">
+              <a:buNone/>
               <a:defRPr sz="1275" b="0">
                 <a:solidFill>
                   <a:srgbClr val="17202A"/>
@@ -9938,6 +10035,7 @@
           <a:lstStyle xmlns:a="http://schemas.openxmlformats.org/drawingml/2006/main"/>
           <a:p xmlns:a="http://schemas.openxmlformats.org/drawingml/2006/main">
             <a:pPr algn="l">
+              <a:buNone/>
               <a:defRPr sz="2025" b="1">
                 <a:solidFill>
                   <a:srgbClr val="2F8F46"/>
@@ -10002,6 +10100,7 @@
           <a:lstStyle xmlns:a="http://schemas.openxmlformats.org/drawingml/2006/main"/>
           <a:p xmlns:a="http://schemas.openxmlformats.org/drawingml/2006/main">
             <a:pPr algn="l">
+              <a:buNone/>
               <a:defRPr sz="1275" b="0">
                 <a:solidFill>
                   <a:srgbClr val="17202A"/>
@@ -10066,6 +10165,7 @@
           <a:lstStyle xmlns:a="http://schemas.openxmlformats.org/drawingml/2006/main"/>
           <a:p xmlns:a="http://schemas.openxmlformats.org/drawingml/2006/main">
             <a:pPr algn="l">
+              <a:buNone/>
               <a:defRPr sz="3900" b="1">
                 <a:solidFill>
                   <a:srgbClr val="168A8A"/>
@@ -10130,6 +10230,7 @@
           <a:lstStyle xmlns:a="http://schemas.openxmlformats.org/drawingml/2006/main"/>
           <a:p xmlns:a="http://schemas.openxmlformats.org/drawingml/2006/main">
             <a:pPr algn="l">
+              <a:buNone/>
               <a:defRPr sz="1125" b="0">
                 <a:solidFill>
                   <a:srgbClr val="5D6673"/>
@@ -10194,6 +10295,7 @@
           <a:lstStyle xmlns:a="http://schemas.openxmlformats.org/drawingml/2006/main"/>
           <a:p xmlns:a="http://schemas.openxmlformats.org/drawingml/2006/main">
             <a:pPr algn="l">
+              <a:buNone/>
               <a:defRPr sz="3900" b="1">
                 <a:solidFill>
                   <a:srgbClr val="C57A16"/>
@@ -10258,6 +10360,7 @@
           <a:lstStyle xmlns:a="http://schemas.openxmlformats.org/drawingml/2006/main"/>
           <a:p xmlns:a="http://schemas.openxmlformats.org/drawingml/2006/main">
             <a:pPr algn="l">
+              <a:buNone/>
               <a:defRPr sz="1125" b="0">
                 <a:solidFill>
                   <a:srgbClr val="5D6673"/>
@@ -10322,6 +10425,7 @@
           <a:lstStyle xmlns:a="http://schemas.openxmlformats.org/drawingml/2006/main"/>
           <a:p xmlns:a="http://schemas.openxmlformats.org/drawingml/2006/main">
             <a:pPr algn="l">
+              <a:buNone/>
               <a:defRPr sz="1500" b="1">
                 <a:solidFill>
                   <a:srgbClr val="17202A"/>
@@ -10386,6 +10490,7 @@
           <a:lstStyle xmlns:a="http://schemas.openxmlformats.org/drawingml/2006/main"/>
           <a:p xmlns:a="http://schemas.openxmlformats.org/drawingml/2006/main">
             <a:pPr algn="l">
+              <a:buNone/>
               <a:defRPr sz="750" b="0">
                 <a:solidFill>
                   <a:srgbClr val="5D6673"/>
@@ -10577,6 +10682,7 @@
           <a:lstStyle xmlns:a="http://schemas.openxmlformats.org/drawingml/2006/main"/>
           <a:p xmlns:a="http://schemas.openxmlformats.org/drawingml/2006/main">
             <a:pPr algn="l">
+              <a:buNone/>
               <a:defRPr sz="825" b="1">
                 <a:solidFill>
                   <a:srgbClr val="5D6673"/>
@@ -10641,6 +10747,7 @@
           <a:lstStyle xmlns:a="http://schemas.openxmlformats.org/drawingml/2006/main"/>
           <a:p xmlns:a="http://schemas.openxmlformats.org/drawingml/2006/main">
             <a:pPr algn="r">
+              <a:buNone/>
               <a:defRPr sz="1125" b="1">
                 <a:solidFill>
                   <a:srgbClr val="5D6673"/>
@@ -10740,6 +10847,7 @@
           <a:lstStyle xmlns:a="http://schemas.openxmlformats.org/drawingml/2006/main"/>
           <a:p xmlns:a="http://schemas.openxmlformats.org/drawingml/2006/main">
             <a:pPr algn="l">
+              <a:buNone/>
               <a:defRPr sz="975" b="1">
                 <a:solidFill>
                   <a:srgbClr val="168A8A"/>
@@ -10804,6 +10912,7 @@
           <a:lstStyle xmlns:a="http://schemas.openxmlformats.org/drawingml/2006/main"/>
           <a:p xmlns:a="http://schemas.openxmlformats.org/drawingml/2006/main">
             <a:pPr algn="l">
+              <a:buNone/>
               <a:defRPr sz="3225" b="1">
                 <a:solidFill>
                   <a:srgbClr val="17202A"/>
@@ -10829,14 +10938,14 @@
       </p:sp>
       <p:pic>
         <p:nvPicPr>
-          <p:cNvPr id="9" name=""/>
+          <p:cNvPr id="25" name=""/>
           <p:cNvPicPr>
             <a:picLocks xmlns:a="http://schemas.openxmlformats.org/drawingml/2006/main" noChangeAspect="1"/>
           </p:cNvPicPr>
           <p:nvPr/>
         </p:nvPicPr>
         <p:blipFill>
-          <a:blip xmlns:r="http://schemas.openxmlformats.org/officeDocument/2006/relationships" xmlns:a="http://schemas.openxmlformats.org/drawingml/2006/main" r:embed="R072cbfdcb9f4413e"/>
+          <a:blip xmlns:r="http://schemas.openxmlformats.org/officeDocument/2006/relationships" xmlns:a="http://schemas.openxmlformats.org/drawingml/2006/main" r:embed="Rd9036e98163048c0"/>
           <a:stretch xmlns:a="http://schemas.openxmlformats.org/drawingml/2006/main"/>
         </p:blipFill>
         <p:spPr>
@@ -10890,6 +10999,7 @@
           <a:lstStyle xmlns:a="http://schemas.openxmlformats.org/drawingml/2006/main"/>
           <a:p xmlns:a="http://schemas.openxmlformats.org/drawingml/2006/main">
             <a:pPr algn="l">
+              <a:buNone/>
               <a:defRPr sz="3900" b="1">
                 <a:solidFill>
                   <a:srgbClr val="215AA6"/>
@@ -10954,6 +11064,7 @@
           <a:lstStyle xmlns:a="http://schemas.openxmlformats.org/drawingml/2006/main"/>
           <a:p xmlns:a="http://schemas.openxmlformats.org/drawingml/2006/main">
             <a:pPr algn="l">
+              <a:buNone/>
               <a:defRPr sz="1125" b="0">
                 <a:solidFill>
                   <a:srgbClr val="5D6673"/>
@@ -11018,6 +11129,7 @@
           <a:lstStyle xmlns:a="http://schemas.openxmlformats.org/drawingml/2006/main"/>
           <a:p xmlns:a="http://schemas.openxmlformats.org/drawingml/2006/main">
             <a:pPr algn="l">
+              <a:buNone/>
               <a:defRPr sz="3900" b="1">
                 <a:solidFill>
                   <a:srgbClr val="2F8F46"/>
@@ -11082,6 +11194,7 @@
           <a:lstStyle xmlns:a="http://schemas.openxmlformats.org/drawingml/2006/main"/>
           <a:p xmlns:a="http://schemas.openxmlformats.org/drawingml/2006/main">
             <a:pPr algn="l">
+              <a:buNone/>
               <a:defRPr sz="1125" b="0">
                 <a:solidFill>
                   <a:srgbClr val="5D6673"/>
@@ -11146,6 +11259,7 @@
           <a:lstStyle xmlns:a="http://schemas.openxmlformats.org/drawingml/2006/main"/>
           <a:p xmlns:a="http://schemas.openxmlformats.org/drawingml/2006/main">
             <a:pPr algn="l">
+              <a:buNone/>
               <a:defRPr sz="1575" b="1">
                 <a:solidFill>
                   <a:srgbClr val="17202A"/>
@@ -11210,6 +11324,7 @@
           <a:lstStyle xmlns:a="http://schemas.openxmlformats.org/drawingml/2006/main"/>
           <a:p xmlns:a="http://schemas.openxmlformats.org/drawingml/2006/main">
             <a:pPr algn="l">
+              <a:buNone/>
               <a:defRPr sz="750" b="0">
                 <a:solidFill>
                   <a:srgbClr val="5D6673"/>
@@ -11401,6 +11516,7 @@
           <a:lstStyle xmlns:a="http://schemas.openxmlformats.org/drawingml/2006/main"/>
           <a:p xmlns:a="http://schemas.openxmlformats.org/drawingml/2006/main">
             <a:pPr algn="l">
+              <a:buNone/>
               <a:defRPr sz="825" b="1">
                 <a:solidFill>
                   <a:srgbClr val="5D6673"/>
@@ -11465,6 +11581,7 @@
           <a:lstStyle xmlns:a="http://schemas.openxmlformats.org/drawingml/2006/main"/>
           <a:p xmlns:a="http://schemas.openxmlformats.org/drawingml/2006/main">
             <a:pPr algn="r">
+              <a:buNone/>
               <a:defRPr sz="1125" b="1">
                 <a:solidFill>
                   <a:srgbClr val="5D6673"/>
@@ -11564,6 +11681,7 @@
           <a:lstStyle xmlns:a="http://schemas.openxmlformats.org/drawingml/2006/main"/>
           <a:p xmlns:a="http://schemas.openxmlformats.org/drawingml/2006/main">
             <a:pPr algn="l">
+              <a:buNone/>
               <a:defRPr sz="975" b="1">
                 <a:solidFill>
                   <a:srgbClr val="168A8A"/>
@@ -11628,6 +11746,7 @@
           <a:lstStyle xmlns:a="http://schemas.openxmlformats.org/drawingml/2006/main"/>
           <a:p xmlns:a="http://schemas.openxmlformats.org/drawingml/2006/main">
             <a:pPr algn="l">
+              <a:buNone/>
               <a:defRPr sz="3225" b="1">
                 <a:solidFill>
                   <a:srgbClr val="17202A"/>
@@ -11653,14 +11772,14 @@
       </p:sp>
       <p:pic>
         <p:nvPicPr>
-          <p:cNvPr id="9" name=""/>
+          <p:cNvPr id="28" name="" hidden="0"/>
           <p:cNvPicPr>
             <a:picLocks xmlns:a="http://schemas.openxmlformats.org/drawingml/2006/main" noChangeAspect="1"/>
           </p:cNvPicPr>
           <p:nvPr/>
         </p:nvPicPr>
         <p:blipFill>
-          <a:blip xmlns:r="http://schemas.openxmlformats.org/officeDocument/2006/relationships" xmlns:a="http://schemas.openxmlformats.org/drawingml/2006/main" r:embed="R55603092da3c4c84"/>
+          <a:blip xmlns:r="http://schemas.openxmlformats.org/officeDocument/2006/relationships" xmlns:a="http://schemas.openxmlformats.org/drawingml/2006/main" r:embed="Raeddb94ca1fa43b7"/>
           <a:stretch xmlns:a="http://schemas.openxmlformats.org/drawingml/2006/main"/>
         </p:blipFill>
         <p:spPr>
@@ -11675,14 +11794,14 @@
       </p:pic>
       <p:pic>
         <p:nvPicPr>
-          <p:cNvPr id="10" name=""/>
+          <p:cNvPr id="29" name=""/>
           <p:cNvPicPr>
             <a:picLocks xmlns:a="http://schemas.openxmlformats.org/drawingml/2006/main" noChangeAspect="1"/>
           </p:cNvPicPr>
           <p:nvPr/>
         </p:nvPicPr>
         <p:blipFill>
-          <a:blip xmlns:r="http://schemas.openxmlformats.org/officeDocument/2006/relationships" xmlns:a="http://schemas.openxmlformats.org/drawingml/2006/main" r:embed="Rc14113933af24ec2"/>
+          <a:blip xmlns:r="http://schemas.openxmlformats.org/officeDocument/2006/relationships" xmlns:a="http://schemas.openxmlformats.org/drawingml/2006/main" r:embed="Rf5c3c7b6f59b4751"/>
           <a:stretch xmlns:a="http://schemas.openxmlformats.org/drawingml/2006/main"/>
         </p:blipFill>
         <p:spPr>
@@ -11736,6 +11855,7 @@
           <a:lstStyle xmlns:a="http://schemas.openxmlformats.org/drawingml/2006/main"/>
           <a:p xmlns:a="http://schemas.openxmlformats.org/drawingml/2006/main">
             <a:pPr algn="l">
+              <a:buNone/>
               <a:defRPr sz="3900" b="1">
                 <a:solidFill>
                   <a:srgbClr val="C57A16"/>
@@ -11754,7 +11874,7 @@
                 <a:ea typeface="Aptos Display"/>
                 <a:cs typeface="Aptos Display"/>
               </a:rPr>
-              <a:t>0.549</a:t>
+              <a:t>0.7644</a:t>
             </a:r>
           </a:p>
         </p:txBody>
@@ -11800,6 +11920,7 @@
           <a:lstStyle xmlns:a="http://schemas.openxmlformats.org/drawingml/2006/main"/>
           <a:p xmlns:a="http://schemas.openxmlformats.org/drawingml/2006/main">
             <a:pPr algn="l">
+              <a:buNone/>
               <a:defRPr sz="1125" b="0">
                 <a:solidFill>
                   <a:srgbClr val="5D6673"/>
@@ -11818,7 +11939,7 @@
                 <a:ea typeface="Aptos"/>
                 <a:cs typeface="Aptos"/>
               </a:rPr>
-              <a:t>selected threshold</a:t>
+              <a:t>final test ROC-AUC</a:t>
             </a:r>
           </a:p>
         </p:txBody>
@@ -11864,6 +11985,7 @@
           <a:lstStyle xmlns:a="http://schemas.openxmlformats.org/drawingml/2006/main"/>
           <a:p xmlns:a="http://schemas.openxmlformats.org/drawingml/2006/main">
             <a:pPr algn="l">
+              <a:buNone/>
               <a:defRPr sz="3900" b="1">
                 <a:solidFill>
                   <a:srgbClr val="168A8A"/>
@@ -11882,7 +12004,7 @@
                 <a:ea typeface="Aptos Display"/>
                 <a:cs typeface="Aptos Display"/>
               </a:rPr>
-              <a:t>0.2545</a:t>
+              <a:t>0.2309</a:t>
             </a:r>
           </a:p>
         </p:txBody>
@@ -11928,6 +12050,7 @@
           <a:lstStyle xmlns:a="http://schemas.openxmlformats.org/drawingml/2006/main"/>
           <a:p xmlns:a="http://schemas.openxmlformats.org/drawingml/2006/main">
             <a:pPr algn="l">
+              <a:buNone/>
               <a:defRPr sz="1125" b="0">
                 <a:solidFill>
                   <a:srgbClr val="5D6673"/>
@@ -11946,7 +12069,7 @@
                 <a:ea typeface="Aptos"/>
                 <a:cs typeface="Aptos"/>
               </a:rPr>
-              <a:t>validation PR-AUC</a:t>
+              <a:t>test PR-AUC</a:t>
             </a:r>
           </a:p>
         </p:txBody>
@@ -11992,6 +12115,7 @@
           <a:lstStyle xmlns:a="http://schemas.openxmlformats.org/drawingml/2006/main"/>
           <a:p xmlns:a="http://schemas.openxmlformats.org/drawingml/2006/main">
             <a:pPr algn="l">
+              <a:buNone/>
               <a:defRPr sz="1650" b="1">
                 <a:solidFill>
                   <a:srgbClr val="17202A"/>
@@ -12056,6 +12180,7 @@
           <a:lstStyle xmlns:a="http://schemas.openxmlformats.org/drawingml/2006/main"/>
           <a:p xmlns:a="http://schemas.openxmlformats.org/drawingml/2006/main">
             <a:pPr algn="l">
+              <a:buNone/>
               <a:defRPr sz="750" b="0">
                 <a:solidFill>
                   <a:srgbClr val="5D6673"/>
@@ -12074,11 +12199,33 @@
                 <a:ea typeface="Aptos"/>
                 <a:cs typeface="Aptos"/>
               </a:rPr>
-              <a:t>Evidence: validation_confusion_matrix.png, cost_sensitivity_threshold_curve.png.</a:t>
-            </a:r>
-          </a:p>
-        </p:txBody>
-      </p:sp>
+              <a:t>Evidence: validation_confusion_matrix.png, cost_sensitivity_threshold_curve.png, training_report.json.</a:t>
+            </a:r>
+          </a:p>
+        </p:txBody>
+      </p:sp>
+      <p:pic>
+        <p:nvPicPr>
+          <p:cNvPr id="36" name="" hidden="1"/>
+          <p:cNvPicPr>
+            <a:picLocks xmlns:a="http://schemas.openxmlformats.org/drawingml/2006/main" noChangeAspect="1"/>
+          </p:cNvPicPr>
+          <p:nvPr/>
+        </p:nvPicPr>
+        <p:blipFill>
+          <a:blip xmlns:r="http://schemas.openxmlformats.org/officeDocument/2006/relationships" xmlns:a="http://schemas.openxmlformats.org/drawingml/2006/main" r:embed="R051b0f9027e84a9a"/>
+          <a:stretch xmlns:a="http://schemas.openxmlformats.org/drawingml/2006/main"/>
+        </p:blipFill>
+        <p:spPr>
+          <a:xfrm xmlns:a="http://schemas.openxmlformats.org/drawingml/2006/main">
+            <a:off x="0" y="0"/>
+            <a:ext cx="914400" cy="914400"/>
+          </a:xfrm>
+          <a:prstGeom xmlns:a="http://schemas.openxmlformats.org/drawingml/2006/main" prst="rect">
+            <a:avLst/>
+          </a:prstGeom>
+        </p:spPr>
+      </p:pic>
     </p:spTree>
     <p:extLst>
       <p:ext uri="{BB962C8B-B14F-4D97-AF65-F5344CB8AC3E}">
@@ -12247,6 +12394,7 @@
           <a:lstStyle xmlns:a="http://schemas.openxmlformats.org/drawingml/2006/main"/>
           <a:p xmlns:a="http://schemas.openxmlformats.org/drawingml/2006/main">
             <a:pPr algn="l">
+              <a:buNone/>
               <a:defRPr sz="825" b="1">
                 <a:solidFill>
                   <a:srgbClr val="5D6673"/>
@@ -12311,6 +12459,7 @@
           <a:lstStyle xmlns:a="http://schemas.openxmlformats.org/drawingml/2006/main"/>
           <a:p xmlns:a="http://schemas.openxmlformats.org/drawingml/2006/main">
             <a:pPr algn="r">
+              <a:buNone/>
               <a:defRPr sz="1125" b="1">
                 <a:solidFill>
                   <a:srgbClr val="5D6673"/>
@@ -12410,6 +12559,7 @@
           <a:lstStyle xmlns:a="http://schemas.openxmlformats.org/drawingml/2006/main"/>
           <a:p xmlns:a="http://schemas.openxmlformats.org/drawingml/2006/main">
             <a:pPr algn="l">
+              <a:buNone/>
               <a:defRPr sz="975" b="1">
                 <a:solidFill>
                   <a:srgbClr val="168A8A"/>
@@ -12474,6 +12624,7 @@
           <a:lstStyle xmlns:a="http://schemas.openxmlformats.org/drawingml/2006/main"/>
           <a:p xmlns:a="http://schemas.openxmlformats.org/drawingml/2006/main">
             <a:pPr algn="l">
+              <a:buNone/>
               <a:defRPr sz="3225" b="1">
                 <a:solidFill>
                   <a:srgbClr val="17202A"/>
@@ -12499,14 +12650,14 @@
       </p:sp>
       <p:pic>
         <p:nvPicPr>
-          <p:cNvPr id="9" name=""/>
+          <p:cNvPr id="23" name=""/>
           <p:cNvPicPr>
             <a:picLocks xmlns:a="http://schemas.openxmlformats.org/drawingml/2006/main" noChangeAspect="1"/>
           </p:cNvPicPr>
           <p:nvPr/>
         </p:nvPicPr>
         <p:blipFill>
-          <a:blip xmlns:r="http://schemas.openxmlformats.org/officeDocument/2006/relationships" xmlns:a="http://schemas.openxmlformats.org/drawingml/2006/main" r:embed="Rdf567a4118dc4bab"/>
+          <a:blip xmlns:r="http://schemas.openxmlformats.org/officeDocument/2006/relationships" xmlns:a="http://schemas.openxmlformats.org/drawingml/2006/main" r:embed="R917f079178364f53"/>
           <a:stretch xmlns:a="http://schemas.openxmlformats.org/drawingml/2006/main"/>
         </p:blipFill>
         <p:spPr>
@@ -12560,6 +12711,7 @@
           <a:lstStyle xmlns:a="http://schemas.openxmlformats.org/drawingml/2006/main"/>
           <a:p xmlns:a="http://schemas.openxmlformats.org/drawingml/2006/main">
             <a:pPr algn="l">
+              <a:buNone/>
               <a:defRPr sz="2250" b="1">
                 <a:solidFill>
                   <a:srgbClr val="168A8A"/>
@@ -12624,6 +12776,7 @@
           <a:lstStyle xmlns:a="http://schemas.openxmlformats.org/drawingml/2006/main"/>
           <a:p xmlns:a="http://schemas.openxmlformats.org/drawingml/2006/main">
             <a:pPr algn="l">
+              <a:buNone/>
               <a:defRPr sz="1650" b="1">
                 <a:solidFill>
                   <a:srgbClr val="17202A"/>
@@ -12688,6 +12841,7 @@
           <a:lstStyle xmlns:a="http://schemas.openxmlformats.org/drawingml/2006/main"/>
           <a:p xmlns:a="http://schemas.openxmlformats.org/drawingml/2006/main">
             <a:pPr algn="l">
+              <a:buNone/>
               <a:defRPr sz="1500" b="0">
                 <a:solidFill>
                   <a:srgbClr val="5D6673"/>
@@ -12752,6 +12906,7 @@
           <a:lstStyle xmlns:a="http://schemas.openxmlformats.org/drawingml/2006/main"/>
           <a:p xmlns:a="http://schemas.openxmlformats.org/drawingml/2006/main">
             <a:pPr algn="l">
+              <a:buNone/>
               <a:defRPr sz="750" b="0">
                 <a:solidFill>
                   <a:srgbClr val="5D6673"/>
@@ -12943,6 +13098,7 @@
           <a:lstStyle xmlns:a="http://schemas.openxmlformats.org/drawingml/2006/main"/>
           <a:p xmlns:a="http://schemas.openxmlformats.org/drawingml/2006/main">
             <a:pPr algn="l">
+              <a:buNone/>
               <a:defRPr sz="825" b="1">
                 <a:solidFill>
                   <a:srgbClr val="5D6673"/>
@@ -13007,6 +13163,7 @@
           <a:lstStyle xmlns:a="http://schemas.openxmlformats.org/drawingml/2006/main"/>
           <a:p xmlns:a="http://schemas.openxmlformats.org/drawingml/2006/main">
             <a:pPr algn="r">
+              <a:buNone/>
               <a:defRPr sz="1125" b="1">
                 <a:solidFill>
                   <a:srgbClr val="5D6673"/>
@@ -13106,6 +13263,7 @@
           <a:lstStyle xmlns:a="http://schemas.openxmlformats.org/drawingml/2006/main"/>
           <a:p xmlns:a="http://schemas.openxmlformats.org/drawingml/2006/main">
             <a:pPr algn="l">
+              <a:buNone/>
               <a:defRPr sz="975" b="1">
                 <a:solidFill>
                   <a:srgbClr val="168A8A"/>
@@ -13170,6 +13328,7 @@
           <a:lstStyle xmlns:a="http://schemas.openxmlformats.org/drawingml/2006/main"/>
           <a:p xmlns:a="http://schemas.openxmlformats.org/drawingml/2006/main">
             <a:pPr algn="l">
+              <a:buNone/>
               <a:defRPr sz="3225" b="1">
                 <a:solidFill>
                   <a:srgbClr val="17202A"/>
@@ -13267,6 +13426,7 @@
           <a:lstStyle xmlns:a="http://schemas.openxmlformats.org/drawingml/2006/main"/>
           <a:p xmlns:a="http://schemas.openxmlformats.org/drawingml/2006/main">
             <a:pPr algn="l">
+              <a:buNone/>
               <a:defRPr sz="2250" b="1">
                 <a:solidFill>
                   <a:srgbClr val="BF5B49"/>
@@ -13331,6 +13491,7 @@
           <a:lstStyle xmlns:a="http://schemas.openxmlformats.org/drawingml/2006/main"/>
           <a:p xmlns:a="http://schemas.openxmlformats.org/drawingml/2006/main">
             <a:pPr algn="l">
+              <a:buNone/>
               <a:defRPr sz="1425" b="0">
                 <a:solidFill>
                   <a:srgbClr val="17202A"/>
@@ -13428,6 +13589,7 @@
           <a:lstStyle xmlns:a="http://schemas.openxmlformats.org/drawingml/2006/main"/>
           <a:p xmlns:a="http://schemas.openxmlformats.org/drawingml/2006/main">
             <a:pPr algn="l">
+              <a:buNone/>
               <a:defRPr sz="2250" b="1">
                 <a:solidFill>
                   <a:srgbClr val="C57A16"/>
@@ -13492,6 +13654,7 @@
           <a:lstStyle xmlns:a="http://schemas.openxmlformats.org/drawingml/2006/main"/>
           <a:p xmlns:a="http://schemas.openxmlformats.org/drawingml/2006/main">
             <a:pPr algn="l">
+              <a:buNone/>
               <a:defRPr sz="1425" b="0">
                 <a:solidFill>
                   <a:srgbClr val="17202A"/>
@@ -13589,6 +13752,7 @@
           <a:lstStyle xmlns:a="http://schemas.openxmlformats.org/drawingml/2006/main"/>
           <a:p xmlns:a="http://schemas.openxmlformats.org/drawingml/2006/main">
             <a:pPr algn="l">
+              <a:buNone/>
               <a:defRPr sz="2250" b="1">
                 <a:solidFill>
                   <a:srgbClr val="6E5AA8"/>
@@ -13653,6 +13817,7 @@
           <a:lstStyle xmlns:a="http://schemas.openxmlformats.org/drawingml/2006/main"/>
           <a:p xmlns:a="http://schemas.openxmlformats.org/drawingml/2006/main">
             <a:pPr algn="l">
+              <a:buNone/>
               <a:defRPr sz="1425" b="0">
                 <a:solidFill>
                   <a:srgbClr val="17202A"/>
@@ -13752,6 +13917,7 @@
           <a:lstStyle xmlns:a="http://schemas.openxmlformats.org/drawingml/2006/main"/>
           <a:p xmlns:a="http://schemas.openxmlformats.org/drawingml/2006/main">
             <a:pPr algn="l">
+              <a:buNone/>
               <a:defRPr sz="1350" b="0">
                 <a:solidFill>
                   <a:srgbClr val="17202A"/>
@@ -13816,6 +13982,7 @@
           <a:lstStyle xmlns:a="http://schemas.openxmlformats.org/drawingml/2006/main"/>
           <a:p xmlns:a="http://schemas.openxmlformats.org/drawingml/2006/main">
             <a:pPr algn="l">
+              <a:buNone/>
               <a:defRPr sz="750" b="0">
                 <a:solidFill>
                   <a:srgbClr val="5D6673"/>

</xml_diff>